<commit_message>
Fix TO-BE erector capacity to 1 (spec-compliant) and update KPIs in slides
</commit_message>
<xml_diff>
--- a/피킹_프로세스_효율화_및_생산성_극대화_20260709235709.pptx
+++ b/피킹_프로세스_효율화_및_생산성_극대화_20260709235709.pptx
@@ -3086,7 +3086,7 @@
           <p:nvPr>
             <p:extLst>
               <p:ext uri="{D42A27DB-BD31-4B8C-83A1-F6EECF244321}">
-                <p14:modId xmlns:p14="http://schemas.microsoft.com/office/powerpoint/2010/main" val="1877277379"/>
+                <p14:modId xmlns:p14="http://schemas.microsoft.com/office/powerpoint/2010/main" val="162875343"/>
               </p:ext>
             </p:extLst>
           </p:nvPr>
@@ -4263,7 +4263,7 @@
                           <a:ea typeface="Pretendard Variable" pitchFamily="34" charset="-122"/>
                           <a:cs typeface="Pretendard Variable" pitchFamily="34" charset="-120"/>
                         </a:rPr>
-                        <a:t>21 팔레트</a:t>
+                        <a:t>20 팔레트</a:t>
                       </a:r>
                       <a:endParaRPr lang="en-US" sz="1200" dirty="0"/>
                     </a:p>
@@ -4327,7 +4327,7 @@
                           <a:ea typeface="Pretendard Variable" pitchFamily="34" charset="-122"/>
                           <a:cs typeface="Pretendard Variable" pitchFamily="34" charset="-120"/>
                         </a:rPr>
-                        <a:t>4.2 팔레트/hr</a:t>
+                        <a:t>4.0 팔레트/hr</a:t>
                       </a:r>
                       <a:endParaRPr lang="en-US" sz="1275" dirty="0">
                         <a:latin typeface="Pretendard Variable" charset="0"/>
@@ -5134,7 +5134,7 @@
                 <a:ea typeface="Pretendard Variable" pitchFamily="34" charset="-122"/>
                 <a:cs typeface="Pretendard Variable" pitchFamily="34" charset="-120"/>
               </a:rPr>
-              <a:t>21 팔레트 · 정상 · 기준</a:t>
+              <a:t>20 팔레트 · 정상 · 기준</a:t>
             </a:r>
             <a:endParaRPr lang="en-US" sz="1100" dirty="0"/>
           </a:p>
@@ -6704,7 +6704,7 @@
                 <a:ea typeface="Pretendard Variable" pitchFamily="34" charset="-122"/>
                 <a:cs typeface="Pretendard Variable" pitchFamily="34" charset="-120"/>
               </a:rPr>
-              <a:t>완료 지점 1 → 3 (5hr)</a:t>
+              <a:t>완료 지점 1 → 4 (5hr)</a:t>
             </a:r>
             <a:endParaRPr lang="en-US" sz="1100" dirty="0"/>
           </a:p>
@@ -6813,7 +6813,7 @@
                 <a:ea typeface="Pretendard Variable" pitchFamily="34" charset="-122"/>
                 <a:cs typeface="Pretendard Variable" pitchFamily="34" charset="-120"/>
               </a:rPr>
-              <a:t>8 → 21</a:t>
+              <a:t>8 → 20</a:t>
             </a:r>
             <a:r>
               <a:rPr lang="en-US" sz="1600" b="1" dirty="0">
@@ -6835,7 +6835,7 @@
                 <a:ea typeface="Pretendard Variable" pitchFamily="34" charset="-122"/>
                 <a:cs typeface="Pretendard Variable" pitchFamily="34" charset="-120"/>
               </a:rPr>
-              <a:t>256 → 672</a:t>
+              <a:t>256 → 640</a:t>
             </a:r>
             <a:r>
               <a:rPr lang="en-US" sz="1600" b="1" dirty="0">
@@ -6857,7 +6857,7 @@
                 <a:ea typeface="Pretendard Variable" pitchFamily="34" charset="-122"/>
                 <a:cs typeface="Pretendard Variable" pitchFamily="34" charset="-120"/>
               </a:rPr>
-              <a:t>1.6 → 4.2 팔레트/hr</a:t>
+              <a:t>1.6 → 4.0 팔레트/hr</a:t>
             </a:r>
             <a:endParaRPr lang="en-US" sz="1600" dirty="0"/>
           </a:p>
@@ -7763,7 +7763,7 @@
                 <a:ea typeface="Pretendard Variable" pitchFamily="34" charset="-122"/>
                 <a:cs typeface="Pretendard Variable" pitchFamily="34" charset="-120"/>
               </a:rPr>
-              <a:t>+162</a:t>
+              <a:t>+150</a:t>
             </a:r>
             <a:r>
               <a:rPr lang="en-US" sz="2400" b="1" kern="0" spc="-112" dirty="0">
@@ -7813,7 +7813,7 @@
                 <a:ea typeface="Pretendard Variable" pitchFamily="34" charset="-122"/>
                 <a:cs typeface="Pretendard Variable" pitchFamily="34" charset="-120"/>
               </a:rPr>
-              <a:t>1.6 → 4.2 팔레트/hr (×2.6)</a:t>
+              <a:t>1.6 → 4.0 팔레트/hr (×2.5)</a:t>
             </a:r>
             <a:endParaRPr lang="en-US" sz="1100" dirty="0"/>
           </a:p>
@@ -7891,7 +7891,7 @@
                 <a:ea typeface="Pretendard Variable" pitchFamily="34" charset="-122"/>
                 <a:cs typeface="Pretendard Variable" pitchFamily="34" charset="-120"/>
               </a:rPr>
-              <a:t>+416</a:t>
+              <a:t>+384</a:t>
             </a:r>
             <a:endParaRPr lang="en-US" sz="3700" dirty="0"/>
           </a:p>
@@ -7930,7 +7930,7 @@
                 <a:ea typeface="Pretendard Variable" pitchFamily="34" charset="-122"/>
                 <a:cs typeface="Pretendard Variable" pitchFamily="34" charset="-120"/>
               </a:rPr>
-              <a:t>256 → 672 박스 (5시간 · 동일 조건)</a:t>
+              <a:t>256 → 640 박스 (5시간 · 동일 조건)</a:t>
             </a:r>
             <a:endParaRPr lang="en-US" sz="1100" dirty="0"/>
           </a:p>
@@ -9165,7 +9165,7 @@
                 <a:ea typeface="Pretendard Variable" pitchFamily="34" charset="-122"/>
                 <a:cs typeface="Pretendard Variable" pitchFamily="34" charset="-120"/>
               </a:rPr>
-              <a:t>3</a:t>
+              <a:t>4</a:t>
             </a:r>
             <a:r>
               <a:rPr lang="en-US" sz="1300" dirty="0">
@@ -9176,7 +9176,7 @@
                 <a:ea typeface="Pretendard Variable" pitchFamily="34" charset="-122"/>
                 <a:cs typeface="Pretendard Variable" pitchFamily="34" charset="-120"/>
               </a:rPr>
-              <a:t>(×3 배)</a:t>
+              <a:t>(×4 배)</a:t>
             </a:r>
             <a:endParaRPr lang="en-US" sz="1200" dirty="0"/>
           </a:p>
@@ -9276,7 +9276,7 @@
                 <a:ea typeface="Pretendard Variable" pitchFamily="34" charset="-122"/>
                 <a:cs typeface="Pretendard Variable" pitchFamily="34" charset="-120"/>
               </a:rPr>
-              <a:t>21</a:t>
+              <a:t>20</a:t>
             </a:r>
             <a:r>
               <a:rPr lang="en-US" sz="1300" dirty="0">
@@ -9287,7 +9287,7 @@
                 <a:ea typeface="Pretendard Variable" pitchFamily="34" charset="-122"/>
                 <a:cs typeface="Pretendard Variable" pitchFamily="34" charset="-120"/>
               </a:rPr>
-              <a:t>(+162%)</a:t>
+              <a:t>(+150%)</a:t>
             </a:r>
             <a:endParaRPr lang="en-US" sz="1200" dirty="0"/>
           </a:p>
@@ -9398,7 +9398,39 @@
                 <a:ea typeface="Pretendard Variable" panose="02000003000000020004" pitchFamily="2" charset="-127"/>
                 <a:cs typeface="Pretendard Variable" panose="02000003000000020004" pitchFamily="2" charset="-127"/>
               </a:rPr>
-              <a:t>추가 설비 0원 · 핵심 전략 3가지 + 안정화 설정으로 처리량 +162% · AGV −15대 · 완료 지점 ×3배</a:t>
+              <a:t>추가 설비 0원 · 핵심 전략 3가지 + 안정화 설정으로 처리량 +1</a:t>
+            </a:r>
+            <a:r>
+              <a:rPr lang="en-US" altLang="ko-KR" sz="1400" b="1" dirty="0">
+                <a:latin typeface="Pretendard Variable" panose="02000003000000020004" pitchFamily="2" charset="-127"/>
+                <a:ea typeface="Pretendard Variable" panose="02000003000000020004" pitchFamily="2" charset="-127"/>
+                <a:cs typeface="Pretendard Variable" panose="02000003000000020004" pitchFamily="2" charset="-127"/>
+              </a:rPr>
+              <a:t>50</a:t>
+            </a:r>
+            <a:r>
+              <a:rPr lang="ko-KR" altLang="ko-KR" sz="1400" b="1" dirty="0">
+                <a:latin typeface="Pretendard Variable" panose="02000003000000020004" pitchFamily="2" charset="-127"/>
+                <a:ea typeface="Pretendard Variable" panose="02000003000000020004" pitchFamily="2" charset="-127"/>
+                <a:cs typeface="Pretendard Variable" panose="02000003000000020004" pitchFamily="2" charset="-127"/>
+              </a:rPr>
+              <a:t>% · AGV −15대 · 완료 지점 ×</a:t>
+            </a:r>
+            <a:r>
+              <a:rPr lang="en-US" altLang="ko-KR" sz="1400" b="1" dirty="0">
+                <a:latin typeface="Pretendard Variable" panose="02000003000000020004" pitchFamily="2" charset="-127"/>
+                <a:ea typeface="Pretendard Variable" panose="02000003000000020004" pitchFamily="2" charset="-127"/>
+                <a:cs typeface="Pretendard Variable" panose="02000003000000020004" pitchFamily="2" charset="-127"/>
+              </a:rPr>
+              <a:t>4</a:t>
+            </a:r>
+            <a:r>
+              <a:rPr lang="ko-KR" altLang="ko-KR" sz="1400" b="1" dirty="0">
+                <a:latin typeface="Pretendard Variable" panose="02000003000000020004" pitchFamily="2" charset="-127"/>
+                <a:ea typeface="Pretendard Variable" panose="02000003000000020004" pitchFamily="2" charset="-127"/>
+                <a:cs typeface="Pretendard Variable" panose="02000003000000020004" pitchFamily="2" charset="-127"/>
+              </a:rPr>
+              <a:t>배</a:t>
             </a:r>
             <a:endParaRPr lang="en-US" sz="1400" b="1" dirty="0">
               <a:latin typeface="Pretendard Variable" panose="02000003000000020004" pitchFamily="2" charset="-127"/>
@@ -10942,7 +10974,7 @@
                 <a:ea typeface="Pretendard Variable" pitchFamily="34" charset="-122"/>
                 <a:cs typeface="Pretendard Variable" pitchFamily="34" charset="-120"/>
               </a:rPr>
-              <a:t>3/60 (×3배)</a:t>
+              <a:t>4/60 (×4배)</a:t>
             </a:r>
             <a:r>
               <a:rPr lang="en-US" sz="1100" dirty="0">
@@ -10986,7 +11018,7 @@
                 <a:ea typeface="Pretendard Variable" pitchFamily="34" charset="-122"/>
                 <a:cs typeface="Pretendard Variable" pitchFamily="34" charset="-120"/>
               </a:rPr>
-              <a:t>21 (+162%)</a:t>
+              <a:t>20 (+150%)</a:t>
             </a:r>
             <a:endParaRPr lang="en-US" sz="1100" dirty="0"/>
           </a:p>
@@ -12716,7 +12748,7 @@
                 <a:ea typeface="Pretendard Variable" pitchFamily="34" charset="-122"/>
                 <a:cs typeface="Pretendard Variable" pitchFamily="34" charset="-120"/>
               </a:rPr>
-              <a:t>+162</a:t>
+              <a:t>+150</a:t>
             </a:r>
             <a:r>
               <a:rPr lang="en-US" sz="2100" b="1" kern="0" spc="-75" dirty="0">
@@ -12766,7 +12798,7 @@
                 <a:ea typeface="Pretendard Variable" pitchFamily="34" charset="-122"/>
                 <a:cs typeface="Pretendard Variable" pitchFamily="34" charset="-120"/>
               </a:rPr>
-              <a:t>1.6 → 4.2 팔레트/hr</a:t>
+              <a:t>1.6 → 4.0 팔레트/hr</a:t>
             </a:r>
             <a:endParaRPr lang="en-US" sz="1100" dirty="0"/>
           </a:p>
@@ -12844,7 +12876,7 @@
                 <a:ea typeface="Pretendard Variable" pitchFamily="34" charset="-122"/>
                 <a:cs typeface="Pretendard Variable" pitchFamily="34" charset="-120"/>
               </a:rPr>
-              <a:t>+416</a:t>
+              <a:t>+384</a:t>
             </a:r>
             <a:endParaRPr lang="en-US" sz="3300" dirty="0"/>
           </a:p>
@@ -12883,7 +12915,7 @@
                 <a:ea typeface="Pretendard Variable" pitchFamily="34" charset="-122"/>
                 <a:cs typeface="Pretendard Variable" pitchFamily="34" charset="-120"/>
               </a:rPr>
-              <a:t>256 → 672 박스</a:t>
+              <a:t>256 → 640 박스</a:t>
             </a:r>
             <a:endParaRPr lang="en-US" sz="1100" dirty="0"/>
           </a:p>
@@ -13089,7 +13121,7 @@
                 <a:ea typeface="Pretendard Variable" pitchFamily="34" charset="-122"/>
                 <a:cs typeface="Pretendard Variable" pitchFamily="34" charset="-120"/>
               </a:rPr>
-              <a:t>×3배</a:t>
+              <a:t>×4배</a:t>
             </a:r>
             <a:endParaRPr lang="en-US" sz="3300" dirty="0"/>
           </a:p>
@@ -13128,7 +13160,18 @@
                 <a:ea typeface="Pretendard Variable" pitchFamily="34" charset="-122"/>
                 <a:cs typeface="Pretendard Variable" pitchFamily="34" charset="-120"/>
               </a:rPr>
-              <a:t>1/60 → 3/60</a:t>
+              <a:t>1/60 </a:t>
+            </a:r>
+            <a:r>
+              <a:rPr lang="en-US" sz="1100">
+                <a:solidFill>
+                  <a:srgbClr val="C9D5EA"/>
+                </a:solidFill>
+                <a:latin typeface="Pretendard Variable" pitchFamily="34" charset="0"/>
+                <a:ea typeface="Pretendard Variable" pitchFamily="34" charset="-122"/>
+                <a:cs typeface="Pretendard Variable" pitchFamily="34" charset="-120"/>
+              </a:rPr>
+              <a:t>→ 4/60</a:t>
             </a:r>
             <a:endParaRPr lang="en-US" sz="1100" dirty="0"/>
           </a:p>
@@ -14541,7 +14584,7 @@
                 <a:ea typeface="Pretendard Variable" pitchFamily="34" charset="-122"/>
                 <a:cs typeface="Pretendard Variable" pitchFamily="34" charset="-120"/>
               </a:rPr>
-              <a:t>+162</a:t>
+              <a:t>+150</a:t>
             </a:r>
             <a:r>
               <a:rPr lang="en-US" sz="1900" b="1" dirty="0">
@@ -14594,7 +14637,7 @@
                 <a:ea typeface="Pretendard Variable" pitchFamily="34" charset="-122"/>
                 <a:cs typeface="Pretendard Variable" pitchFamily="34" charset="-120"/>
               </a:rPr>
-              <a:t>1.6 → 4.2 팔레트/hr · AGV 40→25대</a:t>
+              <a:t>1.6 → 4.0 팔레트/hr · AGV 40→25대</a:t>
             </a:r>
             <a:endParaRPr lang="en-US" sz="1200" dirty="0"/>
           </a:p>
@@ -28223,7 +28266,7 @@
                 <a:ea typeface="Pretendard Variable" pitchFamily="34" charset="-122"/>
                 <a:cs typeface="Pretendard Variable" pitchFamily="34" charset="-120"/>
               </a:rPr>
-              <a:t>동일 5시간 · 동일 8,858박스 입력에서 처리량 +162%</a:t>
+              <a:t>동일 5시간 · 동일 8,858박스 입력에서 처리량 +150%</a:t>
             </a:r>
             <a:endParaRPr lang="en-US" sz="2200" dirty="0"/>
           </a:p>
@@ -28362,7 +28405,7 @@
                 <a:ea typeface="Pretendard Variable" pitchFamily="34" charset="-122"/>
                 <a:cs typeface="Pretendard Variable" pitchFamily="34" charset="-120"/>
               </a:rPr>
-              <a:t>21</a:t>
+              <a:t>20</a:t>
             </a:r>
             <a:r>
               <a:rPr lang="en-US" sz="1600" b="1" kern="0" spc="-75" dirty="0">
@@ -28412,7 +28455,7 @@
                 <a:ea typeface="Pretendard Variable" pitchFamily="34" charset="-122"/>
                 <a:cs typeface="Pretendard Variable" pitchFamily="34" charset="-120"/>
               </a:rPr>
-              <a:t>▲ +162%</a:t>
+              <a:t>▲ +150%</a:t>
             </a:r>
             <a:endParaRPr lang="en-US" sz="1500" dirty="0"/>
           </a:p>
@@ -28451,7 +28494,29 @@
                 <a:ea typeface="Pretendard Variable" pitchFamily="34" charset="-122"/>
                 <a:cs typeface="Pretendard Variable" pitchFamily="34" charset="-120"/>
               </a:rPr>
-              <a:t>256 박스 → 672 박스 (+416 박스)</a:t>
+              <a:t>256 박스 → 640 </a:t>
+            </a:r>
+            <a:r>
+              <a:rPr lang="en-US" sz="1100" dirty="0" err="1">
+                <a:solidFill>
+                  <a:srgbClr val="3A4356"/>
+                </a:solidFill>
+                <a:latin typeface="Pretendard Variable" pitchFamily="34" charset="0"/>
+                <a:ea typeface="Pretendard Variable" pitchFamily="34" charset="-122"/>
+                <a:cs typeface="Pretendard Variable" pitchFamily="34" charset="-120"/>
+              </a:rPr>
+              <a:t>박스</a:t>
+            </a:r>
+            <a:r>
+              <a:rPr lang="en-US" sz="1100" dirty="0">
+                <a:solidFill>
+                  <a:srgbClr val="3A4356"/>
+                </a:solidFill>
+                <a:latin typeface="Pretendard Variable" pitchFamily="34" charset="0"/>
+                <a:ea typeface="Pretendard Variable" pitchFamily="34" charset="-122"/>
+                <a:cs typeface="Pretendard Variable" pitchFamily="34" charset="-120"/>
+              </a:rPr>
+              <a:t> (+384 박스)</a:t>
             </a:r>
             <a:endParaRPr lang="en-US" sz="1100" dirty="0"/>
           </a:p>
@@ -28595,7 +28660,7 @@
                 <a:ea typeface="Pretendard Variable" pitchFamily="34" charset="-122"/>
                 <a:cs typeface="Pretendard Variable" pitchFamily="34" charset="-120"/>
               </a:rPr>
-              <a:t>4.2</a:t>
+              <a:t>4.0</a:t>
             </a:r>
             <a:r>
               <a:rPr lang="en-US" sz="1600" b="1" kern="0" spc="-75" dirty="0">
@@ -28645,7 +28710,7 @@
                 <a:ea typeface="Pretendard Variable" pitchFamily="34" charset="-122"/>
                 <a:cs typeface="Pretendard Variable" pitchFamily="34" charset="-120"/>
               </a:rPr>
-              <a:t>▲ +2.4/hr · ×2.6</a:t>
+              <a:t>▲ +2.4/hr · ×2.5</a:t>
             </a:r>
             <a:endParaRPr lang="en-US" sz="1500" dirty="0"/>
           </a:p>
@@ -28784,7 +28849,7 @@
                 <a:ea typeface="Pretendard Variable" pitchFamily="34" charset="-122"/>
                 <a:cs typeface="Pretendard Variable" pitchFamily="34" charset="-120"/>
               </a:rPr>
-              <a:t>3/60</a:t>
+              <a:t>4/60</a:t>
             </a:r>
             <a:endParaRPr lang="en-US" sz="3300" dirty="0"/>
           </a:p>
@@ -28823,7 +28888,7 @@
                 <a:ea typeface="Pretendard Variable" pitchFamily="34" charset="-122"/>
                 <a:cs typeface="Pretendard Variable" pitchFamily="34" charset="-120"/>
               </a:rPr>
-              <a:t>×3배 · AGV 40→25대</a:t>
+              <a:t>×4배 · AGV 40→25대</a:t>
             </a:r>
             <a:endParaRPr lang="en-US" sz="1500" dirty="0"/>
           </a:p>
@@ -28862,7 +28927,29 @@
                 <a:ea typeface="Pretendard Variable" pitchFamily="34" charset="-122"/>
                 <a:cs typeface="Pretendard Variable" pitchFamily="34" charset="-120"/>
               </a:rPr>
-              <a:t>더 적은 자원으로 </a:t>
+              <a:t>더 적은 </a:t>
+            </a:r>
+            <a:r>
+              <a:rPr lang="en-US" sz="1100" dirty="0" err="1">
+                <a:solidFill>
+                  <a:srgbClr val="3A4356"/>
+                </a:solidFill>
+                <a:latin typeface="Pretendard Variable" pitchFamily="34" charset="0"/>
+                <a:ea typeface="Pretendard Variable" pitchFamily="34" charset="-122"/>
+                <a:cs typeface="Pretendard Variable" pitchFamily="34" charset="-120"/>
+              </a:rPr>
+              <a:t>자원으로</a:t>
+            </a:r>
+            <a:r>
+              <a:rPr lang="en-US" sz="1100" dirty="0">
+                <a:solidFill>
+                  <a:srgbClr val="3A4356"/>
+                </a:solidFill>
+                <a:latin typeface="Pretendard Variable" pitchFamily="34" charset="0"/>
+                <a:ea typeface="Pretendard Variable" pitchFamily="34" charset="-122"/>
+                <a:cs typeface="Pretendard Variable" pitchFamily="34" charset="-120"/>
+              </a:rPr>
+              <a:t> </a:t>
             </a:r>
             <a:r>
               <a:rPr lang="en-US" sz="1100" b="1" dirty="0">
@@ -28873,7 +28960,7 @@
                 <a:ea typeface="Pretendard Variable" pitchFamily="34" charset="-122"/>
                 <a:cs typeface="Pretendard Variable" pitchFamily="34" charset="-120"/>
               </a:rPr>
-              <a:t>3배 지점</a:t>
+              <a:t>4배 지점</a:t>
             </a:r>
             <a:r>
               <a:rPr lang="en-US" sz="1100" dirty="0">
@@ -29118,7 +29205,7 @@
                 <a:ea typeface="Pretendard Variable" pitchFamily="34" charset="-122"/>
                 <a:cs typeface="Pretendard Variable" pitchFamily="34" charset="-120"/>
               </a:rPr>
-              <a:t>25대 · 7.6%</a:t>
+              <a:t>25대 · 7.2%</a:t>
             </a:r>
             <a:endParaRPr lang="en-US" sz="900" dirty="0"/>
           </a:p>
@@ -29157,7 +29244,29 @@
                 <a:ea typeface="Pretendard Variable" pitchFamily="34" charset="-122"/>
                 <a:cs typeface="Pretendard Variable" pitchFamily="34" charset="-120"/>
               </a:rPr>
-              <a:t>672 박스 (+416)</a:t>
+              <a:t>640 </a:t>
+            </a:r>
+            <a:r>
+              <a:rPr lang="en-US" sz="1100" b="1" dirty="0" err="1">
+                <a:solidFill>
+                  <a:srgbClr val="2E7D32"/>
+                </a:solidFill>
+                <a:latin typeface="Pretendard Variable" pitchFamily="34" charset="0"/>
+                <a:ea typeface="Pretendard Variable" pitchFamily="34" charset="-122"/>
+                <a:cs typeface="Pretendard Variable" pitchFamily="34" charset="-120"/>
+              </a:rPr>
+              <a:t>박스</a:t>
+            </a:r>
+            <a:r>
+              <a:rPr lang="en-US" sz="1100" b="1" dirty="0">
+                <a:solidFill>
+                  <a:srgbClr val="2E7D32"/>
+                </a:solidFill>
+                <a:latin typeface="Pretendard Variable" pitchFamily="34" charset="0"/>
+                <a:ea typeface="Pretendard Variable" pitchFamily="34" charset="-122"/>
+                <a:cs typeface="Pretendard Variable" pitchFamily="34" charset="-120"/>
+              </a:rPr>
+              <a:t> (+384)</a:t>
             </a:r>
             <a:endParaRPr lang="en-US" sz="1100" dirty="0"/>
           </a:p>
@@ -29211,7 +29320,7 @@
           <p:nvPr>
             <p:extLst>
               <p:ext uri="{D42A27DB-BD31-4B8C-83A1-F6EECF244321}">
-                <p14:modId xmlns:p14="http://schemas.microsoft.com/office/powerpoint/2010/main" val="2487067669"/>
+                <p14:modId xmlns:p14="http://schemas.microsoft.com/office/powerpoint/2010/main" val="751159418"/>
               </p:ext>
             </p:extLst>
           </p:nvPr>
@@ -29687,7 +29796,7 @@
                           <a:ea typeface="Pretendard Variable" pitchFamily="34" charset="-122"/>
                           <a:cs typeface="Pretendard Variable" pitchFamily="34" charset="-120"/>
                         </a:rPr>
-                        <a:t>21 팔레트</a:t>
+                        <a:t>20 팔레트</a:t>
                       </a:r>
                       <a:endParaRPr lang="en-US" sz="1125" dirty="0">
                         <a:latin typeface="Pretendard Variable" charset="0"/>
@@ -29755,7 +29864,7 @@
                           <a:ea typeface="Pretendard Variable" pitchFamily="34" charset="-122"/>
                           <a:cs typeface="Pretendard Variable" pitchFamily="34" charset="-120"/>
                         </a:rPr>
-                        <a:t>▲ +162% (×2.6)</a:t>
+                        <a:t>▲ +150% (×2.5)</a:t>
                       </a:r>
                       <a:endParaRPr lang="en-US" sz="1125" dirty="0">
                         <a:latin typeface="Pretendard Variable" charset="0"/>
@@ -29966,7 +30075,7 @@
                           <a:ea typeface="Pretendard Variable" pitchFamily="34" charset="-122"/>
                           <a:cs typeface="Pretendard Variable" pitchFamily="34" charset="-120"/>
                         </a:rPr>
-                        <a:t>672 박스</a:t>
+                        <a:t>640 박스</a:t>
                       </a:r>
                       <a:endParaRPr lang="en-US" sz="1125" dirty="0">
                         <a:latin typeface="Pretendard Variable" charset="0"/>
@@ -30034,7 +30143,7 @@
                           <a:ea typeface="Pretendard Variable" pitchFamily="34" charset="-122"/>
                           <a:cs typeface="Pretendard Variable" pitchFamily="34" charset="-120"/>
                         </a:rPr>
-                        <a:t>▲ +416 박스</a:t>
+                        <a:t>▲ +384 박스</a:t>
                       </a:r>
                       <a:endParaRPr lang="en-US" sz="1125" dirty="0">
                         <a:latin typeface="Pretendard Variable" charset="0"/>
@@ -30245,7 +30354,7 @@
                           <a:ea typeface="Pretendard Variable" pitchFamily="34" charset="-122"/>
                           <a:cs typeface="Pretendard Variable" pitchFamily="34" charset="-120"/>
                         </a:rPr>
-                        <a:t>3 / 60</a:t>
+                        <a:t>4 / 60</a:t>
                       </a:r>
                       <a:endParaRPr lang="en-US" sz="1125" dirty="0">
                         <a:latin typeface="Pretendard Variable" charset="0"/>
@@ -30313,7 +30422,7 @@
                           <a:ea typeface="Pretendard Variable" pitchFamily="34" charset="-122"/>
                           <a:cs typeface="Pretendard Variable" pitchFamily="34" charset="-120"/>
                         </a:rPr>
-                        <a:t>×3 배</a:t>
+                        <a:t>×4 배</a:t>
                       </a:r>
                       <a:endParaRPr lang="en-US" sz="1125" dirty="0">
                         <a:latin typeface="Pretendard Variable" charset="0"/>
@@ -30546,7 +30655,7 @@
                           <a:ea typeface="Pretendard Variable" pitchFamily="34" charset="-122"/>
                           <a:cs typeface="Pretendard Variable" pitchFamily="34" charset="-120"/>
                         </a:rPr>
-                        <a:t>4.2 팔레트/hr</a:t>
+                        <a:t>4.0 팔레트/hr</a:t>
                       </a:r>
                       <a:endParaRPr lang="en-US" sz="1125" dirty="0">
                         <a:latin typeface="Pretendard Variable" charset="0"/>

</xml_diff>